<commit_message>
Update presentation styling with 3D design and higher text contrast
</commit_message>
<xml_diff>
--- a/TrustLayer_Pitch_Deck.pptx
+++ b/TrustLayer_Pitch_Deck.pptx
@@ -3199,7 +3199,7 @@
             <a:pPr algn="l">
               <a:defRPr sz="2000" b="1" i="0">
                 <a:solidFill>
-                  <a:srgbClr val="00A896"/>
+                  <a:srgbClr val="C8F2EC"/>
                 </a:solidFill>
                 <a:latin typeface="Calibri"/>
               </a:defRPr>
@@ -3253,6 +3253,49 @@
       <p:sp>
         <p:nvSpPr>
           <p:cNvPr id="6" name="Rounded Rectangle 5"/>
+          <p:cNvSpPr/>
+          <p:nvPr/>
+        </p:nvSpPr>
+        <p:spPr>
+          <a:xfrm>
+            <a:off x="7388352" y="987552"/>
+            <a:ext cx="3931920" cy="5029200"/>
+          </a:xfrm>
+          <a:prstGeom prst="roundRect">
+            <a:avLst/>
+          </a:prstGeom>
+          <a:solidFill>
+            <a:srgbClr val="00191C"/>
+          </a:solidFill>
+          <a:ln>
+            <a:noFill/>
+          </a:ln>
+        </p:spPr>
+        <p:style>
+          <a:lnRef idx="1">
+            <a:schemeClr val="accent1"/>
+          </a:lnRef>
+          <a:fillRef idx="3">
+            <a:schemeClr val="accent1"/>
+          </a:fillRef>
+          <a:effectRef idx="2">
+            <a:schemeClr val="accent1"/>
+          </a:effectRef>
+          <a:fontRef idx="minor">
+            <a:schemeClr val="lt1"/>
+          </a:fontRef>
+        </p:style>
+        <p:txBody>
+          <a:bodyPr rtlCol="0" anchor="ctr"/>
+          <a:lstStyle/>
+          <a:p>
+            <a:pPr algn="ctr"/>
+          </a:p>
+        </p:txBody>
+      </p:sp>
+      <p:sp>
+        <p:nvSpPr>
+          <p:cNvPr id="7" name="Rounded Rectangle 6"/>
           <p:cNvSpPr/>
           <p:nvPr/>
         </p:nvSpPr>
@@ -3321,7 +3364,7 @@
             <a:pPr>
               <a:defRPr sz="1100">
                 <a:solidFill>
-                  <a:srgbClr val="00A896"/>
+                  <a:srgbClr val="C8F2EC"/>
                 </a:solidFill>
                 <a:latin typeface="Calibri"/>
               </a:defRPr>
@@ -3350,7 +3393,7 @@
             <a:pPr>
               <a:defRPr sz="1100">
                 <a:solidFill>
-                  <a:srgbClr val="00A896"/>
+                  <a:srgbClr val="C8F2EC"/>
                 </a:solidFill>
                 <a:latin typeface="Calibri"/>
               </a:defRPr>
@@ -3405,7 +3448,7 @@
             <a:pPr>
               <a:defRPr sz="1000">
                 <a:solidFill>
-                  <a:srgbClr val="00A896"/>
+                  <a:srgbClr val="C8F2EC"/>
                 </a:solidFill>
                 <a:latin typeface="Calibri"/>
               </a:defRPr>
@@ -3535,6 +3578,49 @@
         </p:nvSpPr>
         <p:spPr>
           <a:xfrm>
+            <a:off x="978408" y="2258568"/>
+            <a:ext cx="3200400" cy="3474720"/>
+          </a:xfrm>
+          <a:prstGeom prst="roundRect">
+            <a:avLst/>
+          </a:prstGeom>
+          <a:solidFill>
+            <a:srgbClr val="D7DEDE"/>
+          </a:solidFill>
+          <a:ln>
+            <a:noFill/>
+          </a:ln>
+        </p:spPr>
+        <p:style>
+          <a:lnRef idx="1">
+            <a:schemeClr val="accent1"/>
+          </a:lnRef>
+          <a:fillRef idx="3">
+            <a:schemeClr val="accent1"/>
+          </a:fillRef>
+          <a:effectRef idx="2">
+            <a:schemeClr val="accent1"/>
+          </a:effectRef>
+          <a:fontRef idx="minor">
+            <a:schemeClr val="lt1"/>
+          </a:fontRef>
+        </p:style>
+        <p:txBody>
+          <a:bodyPr rtlCol="0" anchor="ctr"/>
+          <a:lstStyle/>
+          <a:p>
+            <a:pPr algn="ctr"/>
+          </a:p>
+        </p:txBody>
+      </p:sp>
+      <p:sp>
+        <p:nvSpPr>
+          <p:cNvPr id="5" name="Rounded Rectangle 4"/>
+          <p:cNvSpPr/>
+          <p:nvPr/>
+        </p:nvSpPr>
+        <p:spPr>
+          <a:xfrm>
             <a:off x="914400" y="2194560"/>
             <a:ext cx="3200400" cy="3474720"/>
           </a:xfrm>
@@ -3544,9 +3630,9 @@
           <a:solidFill>
             <a:srgbClr val="FFFFFF"/>
           </a:solidFill>
-          <a:ln w="12700">
+          <a:ln w="19050">
             <a:solidFill>
-              <a:srgbClr val="D2DCDC"/>
+              <a:srgbClr val="0E2A2D"/>
             </a:solidFill>
           </a:ln>
         </p:spPr>
@@ -3611,7 +3697,50 @@
       </p:sp>
       <p:sp>
         <p:nvSpPr>
-          <p:cNvPr id="5" name="Rounded Rectangle 4"/>
+          <p:cNvPr id="6" name="Rounded Rectangle 5"/>
+          <p:cNvSpPr/>
+          <p:nvPr/>
+        </p:nvSpPr>
+        <p:spPr>
+          <a:xfrm>
+            <a:off x="4544568" y="2258568"/>
+            <a:ext cx="3200400" cy="3474720"/>
+          </a:xfrm>
+          <a:prstGeom prst="roundRect">
+            <a:avLst/>
+          </a:prstGeom>
+          <a:solidFill>
+            <a:srgbClr val="D7DEDE"/>
+          </a:solidFill>
+          <a:ln>
+            <a:noFill/>
+          </a:ln>
+        </p:spPr>
+        <p:style>
+          <a:lnRef idx="1">
+            <a:schemeClr val="accent1"/>
+          </a:lnRef>
+          <a:fillRef idx="3">
+            <a:schemeClr val="accent1"/>
+          </a:fillRef>
+          <a:effectRef idx="2">
+            <a:schemeClr val="accent1"/>
+          </a:effectRef>
+          <a:fontRef idx="minor">
+            <a:schemeClr val="lt1"/>
+          </a:fontRef>
+        </p:style>
+        <p:txBody>
+          <a:bodyPr rtlCol="0" anchor="ctr"/>
+          <a:lstStyle/>
+          <a:p>
+            <a:pPr algn="ctr"/>
+          </a:p>
+        </p:txBody>
+      </p:sp>
+      <p:sp>
+        <p:nvSpPr>
+          <p:cNvPr id="7" name="Rounded Rectangle 6"/>
           <p:cNvSpPr/>
           <p:nvPr/>
         </p:nvSpPr>
@@ -3626,9 +3755,9 @@
           <a:solidFill>
             <a:srgbClr val="FFFFFF"/>
           </a:solidFill>
-          <a:ln w="12700">
+          <a:ln w="19050">
             <a:solidFill>
-              <a:srgbClr val="D2DCDC"/>
+              <a:srgbClr val="0E2A2D"/>
             </a:solidFill>
           </a:ln>
         </p:spPr>
@@ -3693,7 +3822,50 @@
       </p:sp>
       <p:sp>
         <p:nvSpPr>
-          <p:cNvPr id="6" name="Rounded Rectangle 5"/>
+          <p:cNvPr id="8" name="Rounded Rectangle 7"/>
+          <p:cNvSpPr/>
+          <p:nvPr/>
+        </p:nvSpPr>
+        <p:spPr>
+          <a:xfrm>
+            <a:off x="8110728" y="2258568"/>
+            <a:ext cx="3200400" cy="3474720"/>
+          </a:xfrm>
+          <a:prstGeom prst="roundRect">
+            <a:avLst/>
+          </a:prstGeom>
+          <a:solidFill>
+            <a:srgbClr val="D7DEDE"/>
+          </a:solidFill>
+          <a:ln>
+            <a:noFill/>
+          </a:ln>
+        </p:spPr>
+        <p:style>
+          <a:lnRef idx="1">
+            <a:schemeClr val="accent1"/>
+          </a:lnRef>
+          <a:fillRef idx="3">
+            <a:schemeClr val="accent1"/>
+          </a:fillRef>
+          <a:effectRef idx="2">
+            <a:schemeClr val="accent1"/>
+          </a:effectRef>
+          <a:fontRef idx="minor">
+            <a:schemeClr val="lt1"/>
+          </a:fontRef>
+        </p:style>
+        <p:txBody>
+          <a:bodyPr rtlCol="0" anchor="ctr"/>
+          <a:lstStyle/>
+          <a:p>
+            <a:pPr algn="ctr"/>
+          </a:p>
+        </p:txBody>
+      </p:sp>
+      <p:sp>
+        <p:nvSpPr>
+          <p:cNvPr id="9" name="Rounded Rectangle 8"/>
           <p:cNvSpPr/>
           <p:nvPr/>
         </p:nvSpPr>
@@ -3708,9 +3880,9 @@
           <a:solidFill>
             <a:srgbClr val="FFFFFF"/>
           </a:solidFill>
-          <a:ln w="12700">
+          <a:ln w="19050">
             <a:solidFill>
-              <a:srgbClr val="D2DCDC"/>
+              <a:srgbClr val="0E2A2D"/>
             </a:solidFill>
           </a:ln>
         </p:spPr>
@@ -4003,6 +4175,49 @@
         </p:nvSpPr>
         <p:spPr>
           <a:xfrm>
+            <a:off x="6291072" y="1536192"/>
+            <a:ext cx="5029200" cy="4572000"/>
+          </a:xfrm>
+          <a:prstGeom prst="roundRect">
+            <a:avLst/>
+          </a:prstGeom>
+          <a:solidFill>
+            <a:srgbClr val="D7DEDE"/>
+          </a:solidFill>
+          <a:ln>
+            <a:noFill/>
+          </a:ln>
+        </p:spPr>
+        <p:style>
+          <a:lnRef idx="1">
+            <a:schemeClr val="accent1"/>
+          </a:lnRef>
+          <a:fillRef idx="3">
+            <a:schemeClr val="accent1"/>
+          </a:fillRef>
+          <a:effectRef idx="2">
+            <a:schemeClr val="accent1"/>
+          </a:effectRef>
+          <a:fontRef idx="minor">
+            <a:schemeClr val="lt1"/>
+          </a:fontRef>
+        </p:style>
+        <p:txBody>
+          <a:bodyPr rtlCol="0" anchor="ctr"/>
+          <a:lstStyle/>
+          <a:p>
+            <a:pPr algn="ctr"/>
+          </a:p>
+        </p:txBody>
+      </p:sp>
+      <p:sp>
+        <p:nvSpPr>
+          <p:cNvPr id="8" name="Rounded Rectangle 7"/>
+          <p:cNvSpPr/>
+          <p:nvPr/>
+        </p:nvSpPr>
+        <p:spPr>
+          <a:xfrm>
             <a:off x="6217920" y="1463040"/>
             <a:ext cx="5029200" cy="4572000"/>
           </a:xfrm>
@@ -4040,20 +4255,20 @@
       </p:sp>
       <p:sp>
         <p:nvSpPr>
-          <p:cNvPr id="8" name="Rounded Rectangle 7"/>
+          <p:cNvPr id="9" name="Rounded Rectangle 8"/>
           <p:cNvSpPr/>
           <p:nvPr/>
         </p:nvSpPr>
         <p:spPr>
           <a:xfrm>
-            <a:off x="6995160" y="1737360"/>
+            <a:off x="7022592" y="1764792"/>
             <a:ext cx="3474720" cy="502920"/>
           </a:xfrm>
           <a:prstGeom prst="roundRect">
             <a:avLst/>
           </a:prstGeom>
           <a:solidFill>
-            <a:srgbClr val="00A896"/>
+            <a:srgbClr val="002328"/>
           </a:solidFill>
           <a:ln>
             <a:noFill/>
@@ -4074,55 +4289,10 @@
           </a:fontRef>
         </p:style>
         <p:txBody>
-          <a:bodyPr rtlCol="0" anchor="ctr" wrap="square" lIns="45720" rIns="45720"/>
-          <a:lstStyle/>
-          <a:p>
-            <a:pPr algn="ctr">
-              <a:defRPr sz="1200" b="0">
-                <a:solidFill>
-                  <a:srgbClr val="FFFFFF"/>
-                </a:solidFill>
-              </a:defRPr>
-            </a:pPr>
-            <a:r>
-              <a:t>Research Agent</a:t>
-            </a:r>
-          </a:p>
-        </p:txBody>
-      </p:sp>
-      <p:sp>
-        <p:nvSpPr>
-          <p:cNvPr id="9" name="TextBox 8"/>
-          <p:cNvSpPr txBox="1"/>
-          <p:nvPr/>
-        </p:nvSpPr>
-        <p:spPr>
-          <a:xfrm>
-            <a:off x="6995160" y="2258568"/>
-            <a:ext cx="3474720" cy="182880"/>
-          </a:xfrm>
-          <a:prstGeom prst="rect">
-            <a:avLst/>
-          </a:prstGeom>
-          <a:noFill/>
-        </p:spPr>
-        <p:txBody>
-          <a:bodyPr wrap="square" lIns="0" rIns="0" tIns="0" bIns="0">
-            <a:spAutoFit/>
-          </a:bodyPr>
-          <a:lstStyle/>
-          <a:p>
-            <a:pPr algn="ctr">
-              <a:defRPr sz="800" b="0" i="0">
-                <a:solidFill>
-                  <a:srgbClr val="00A896"/>
-                </a:solidFill>
-                <a:latin typeface="Calibri"/>
-              </a:defRPr>
-            </a:pPr>
-            <a:r>
-              <a:t>▼</a:t>
-            </a:r>
+          <a:bodyPr rtlCol="0" anchor="ctr"/>
+          <a:lstStyle/>
+          <a:p>
+            <a:pPr algn="ctr"/>
           </a:p>
         </p:txBody>
       </p:sp>
@@ -4134,7 +4304,7 @@
         </p:nvSpPr>
         <p:spPr>
           <a:xfrm>
-            <a:off x="6995160" y="2478024"/>
+            <a:off x="6995160" y="1737360"/>
             <a:ext cx="3474720" cy="502920"/>
           </a:xfrm>
           <a:prstGeom prst="roundRect">
@@ -4166,14 +4336,14 @@
           <a:lstStyle/>
           <a:p>
             <a:pPr algn="ctr">
-              <a:defRPr sz="1200" b="0">
+              <a:defRPr sz="1200" b="1">
                 <a:solidFill>
                   <a:srgbClr val="FFFFFF"/>
                 </a:solidFill>
               </a:defRPr>
             </a:pPr>
             <a:r>
-              <a:t>Stage 1 Fast Check</a:t>
+              <a:t>Research Agent</a:t>
             </a:r>
           </a:p>
         </p:txBody>
@@ -4186,7 +4356,7 @@
         </p:nvSpPr>
         <p:spPr>
           <a:xfrm>
-            <a:off x="6995160" y="2999232"/>
+            <a:off x="6995160" y="2258568"/>
             <a:ext cx="3474720" cy="182880"/>
           </a:xfrm>
           <a:prstGeom prst="rect">
@@ -4203,7 +4373,7 @@
             <a:pPr algn="ctr">
               <a:defRPr sz="800" b="0" i="0">
                 <a:solidFill>
-                  <a:srgbClr val="00A896"/>
+                  <a:srgbClr val="02C39A"/>
                 </a:solidFill>
                 <a:latin typeface="Calibri"/>
               </a:defRPr>
@@ -4217,6 +4387,180 @@
       <p:sp>
         <p:nvSpPr>
           <p:cNvPr id="12" name="Rounded Rectangle 11"/>
+          <p:cNvSpPr/>
+          <p:nvPr/>
+        </p:nvSpPr>
+        <p:spPr>
+          <a:xfrm>
+            <a:off x="7022592" y="2505456"/>
+            <a:ext cx="3474720" cy="502920"/>
+          </a:xfrm>
+          <a:prstGeom prst="roundRect">
+            <a:avLst/>
+          </a:prstGeom>
+          <a:solidFill>
+            <a:srgbClr val="002328"/>
+          </a:solidFill>
+          <a:ln>
+            <a:noFill/>
+          </a:ln>
+        </p:spPr>
+        <p:style>
+          <a:lnRef idx="1">
+            <a:schemeClr val="accent1"/>
+          </a:lnRef>
+          <a:fillRef idx="3">
+            <a:schemeClr val="accent1"/>
+          </a:fillRef>
+          <a:effectRef idx="2">
+            <a:schemeClr val="accent1"/>
+          </a:effectRef>
+          <a:fontRef idx="minor">
+            <a:schemeClr val="lt1"/>
+          </a:fontRef>
+        </p:style>
+        <p:txBody>
+          <a:bodyPr rtlCol="0" anchor="ctr"/>
+          <a:lstStyle/>
+          <a:p>
+            <a:pPr algn="ctr"/>
+          </a:p>
+        </p:txBody>
+      </p:sp>
+      <p:sp>
+        <p:nvSpPr>
+          <p:cNvPr id="13" name="Rounded Rectangle 12"/>
+          <p:cNvSpPr/>
+          <p:nvPr/>
+        </p:nvSpPr>
+        <p:spPr>
+          <a:xfrm>
+            <a:off x="6995160" y="2478024"/>
+            <a:ext cx="3474720" cy="502920"/>
+          </a:xfrm>
+          <a:prstGeom prst="roundRect">
+            <a:avLst/>
+          </a:prstGeom>
+          <a:solidFill>
+            <a:srgbClr val="028090"/>
+          </a:solidFill>
+          <a:ln>
+            <a:noFill/>
+          </a:ln>
+        </p:spPr>
+        <p:style>
+          <a:lnRef idx="1">
+            <a:schemeClr val="accent1"/>
+          </a:lnRef>
+          <a:fillRef idx="3">
+            <a:schemeClr val="accent1"/>
+          </a:fillRef>
+          <a:effectRef idx="2">
+            <a:schemeClr val="accent1"/>
+          </a:effectRef>
+          <a:fontRef idx="minor">
+            <a:schemeClr val="lt1"/>
+          </a:fontRef>
+        </p:style>
+        <p:txBody>
+          <a:bodyPr rtlCol="0" anchor="ctr" wrap="square" lIns="45720" rIns="45720"/>
+          <a:lstStyle/>
+          <a:p>
+            <a:pPr algn="ctr">
+              <a:defRPr sz="1200" b="1">
+                <a:solidFill>
+                  <a:srgbClr val="FFFFFF"/>
+                </a:solidFill>
+              </a:defRPr>
+            </a:pPr>
+            <a:r>
+              <a:t>Stage 1 Fast Check</a:t>
+            </a:r>
+          </a:p>
+        </p:txBody>
+      </p:sp>
+      <p:sp>
+        <p:nvSpPr>
+          <p:cNvPr id="14" name="TextBox 13"/>
+          <p:cNvSpPr txBox="1"/>
+          <p:nvPr/>
+        </p:nvSpPr>
+        <p:spPr>
+          <a:xfrm>
+            <a:off x="6995160" y="2999232"/>
+            <a:ext cx="3474720" cy="182880"/>
+          </a:xfrm>
+          <a:prstGeom prst="rect">
+            <a:avLst/>
+          </a:prstGeom>
+          <a:noFill/>
+        </p:spPr>
+        <p:txBody>
+          <a:bodyPr wrap="square" lIns="0" rIns="0" tIns="0" bIns="0">
+            <a:spAutoFit/>
+          </a:bodyPr>
+          <a:lstStyle/>
+          <a:p>
+            <a:pPr algn="ctr">
+              <a:defRPr sz="800" b="0" i="0">
+                <a:solidFill>
+                  <a:srgbClr val="02C39A"/>
+                </a:solidFill>
+                <a:latin typeface="Calibri"/>
+              </a:defRPr>
+            </a:pPr>
+            <a:r>
+              <a:t>▼</a:t>
+            </a:r>
+          </a:p>
+        </p:txBody>
+      </p:sp>
+      <p:sp>
+        <p:nvSpPr>
+          <p:cNvPr id="15" name="Rounded Rectangle 14"/>
+          <p:cNvSpPr/>
+          <p:nvPr/>
+        </p:nvSpPr>
+        <p:spPr>
+          <a:xfrm>
+            <a:off x="7022592" y="3246120"/>
+            <a:ext cx="3474720" cy="502920"/>
+          </a:xfrm>
+          <a:prstGeom prst="roundRect">
+            <a:avLst/>
+          </a:prstGeom>
+          <a:solidFill>
+            <a:srgbClr val="002328"/>
+          </a:solidFill>
+          <a:ln>
+            <a:noFill/>
+          </a:ln>
+        </p:spPr>
+        <p:style>
+          <a:lnRef idx="1">
+            <a:schemeClr val="accent1"/>
+          </a:lnRef>
+          <a:fillRef idx="3">
+            <a:schemeClr val="accent1"/>
+          </a:fillRef>
+          <a:effectRef idx="2">
+            <a:schemeClr val="accent1"/>
+          </a:effectRef>
+          <a:fontRef idx="minor">
+            <a:schemeClr val="lt1"/>
+          </a:fontRef>
+        </p:style>
+        <p:txBody>
+          <a:bodyPr rtlCol="0" anchor="ctr"/>
+          <a:lstStyle/>
+          <a:p>
+            <a:pPr algn="ctr"/>
+          </a:p>
+        </p:txBody>
+      </p:sp>
+      <p:sp>
+        <p:nvSpPr>
+          <p:cNvPr id="16" name="Rounded Rectangle 15"/>
           <p:cNvSpPr/>
           <p:nvPr/>
         </p:nvSpPr>
@@ -4268,7 +4612,7 @@
       </p:sp>
       <p:sp>
         <p:nvSpPr>
-          <p:cNvPr id="13" name="TextBox 12"/>
+          <p:cNvPr id="17" name="TextBox 16"/>
           <p:cNvSpPr txBox="1"/>
           <p:nvPr/>
         </p:nvSpPr>
@@ -4291,7 +4635,7 @@
             <a:pPr algn="ctr">
               <a:defRPr sz="800" b="0" i="0">
                 <a:solidFill>
-                  <a:srgbClr val="00A896"/>
+                  <a:srgbClr val="02C39A"/>
                 </a:solidFill>
                 <a:latin typeface="Calibri"/>
               </a:defRPr>
@@ -4304,7 +4648,50 @@
       </p:sp>
       <p:sp>
         <p:nvSpPr>
-          <p:cNvPr id="14" name="Rounded Rectangle 13"/>
+          <p:cNvPr id="18" name="Rounded Rectangle 17"/>
+          <p:cNvSpPr/>
+          <p:nvPr/>
+        </p:nvSpPr>
+        <p:spPr>
+          <a:xfrm>
+            <a:off x="7022592" y="3986784"/>
+            <a:ext cx="3474720" cy="502920"/>
+          </a:xfrm>
+          <a:prstGeom prst="roundRect">
+            <a:avLst/>
+          </a:prstGeom>
+          <a:solidFill>
+            <a:srgbClr val="002328"/>
+          </a:solidFill>
+          <a:ln>
+            <a:noFill/>
+          </a:ln>
+        </p:spPr>
+        <p:style>
+          <a:lnRef idx="1">
+            <a:schemeClr val="accent1"/>
+          </a:lnRef>
+          <a:fillRef idx="3">
+            <a:schemeClr val="accent1"/>
+          </a:fillRef>
+          <a:effectRef idx="2">
+            <a:schemeClr val="accent1"/>
+          </a:effectRef>
+          <a:fontRef idx="minor">
+            <a:schemeClr val="lt1"/>
+          </a:fontRef>
+        </p:style>
+        <p:txBody>
+          <a:bodyPr rtlCol="0" anchor="ctr"/>
+          <a:lstStyle/>
+          <a:p>
+            <a:pPr algn="ctr"/>
+          </a:p>
+        </p:txBody>
+      </p:sp>
+      <p:sp>
+        <p:nvSpPr>
+          <p:cNvPr id="19" name="Rounded Rectangle 18"/>
           <p:cNvSpPr/>
           <p:nvPr/>
         </p:nvSpPr>
@@ -4342,7 +4729,7 @@
           <a:lstStyle/>
           <a:p>
             <a:pPr algn="ctr">
-              <a:defRPr sz="1200" b="0">
+              <a:defRPr sz="1200" b="1">
                 <a:solidFill>
                   <a:srgbClr val="FFFFFF"/>
                 </a:solidFill>
@@ -4356,7 +4743,7 @@
       </p:sp>
       <p:sp>
         <p:nvSpPr>
-          <p:cNvPr id="15" name="TextBox 14"/>
+          <p:cNvPr id="20" name="TextBox 19"/>
           <p:cNvSpPr txBox="1"/>
           <p:nvPr/>
         </p:nvSpPr>
@@ -4379,7 +4766,7 @@
             <a:pPr algn="ctr">
               <a:defRPr sz="800" b="0" i="0">
                 <a:solidFill>
-                  <a:srgbClr val="00A896"/>
+                  <a:srgbClr val="02C39A"/>
                 </a:solidFill>
                 <a:latin typeface="Calibri"/>
               </a:defRPr>
@@ -4392,7 +4779,50 @@
       </p:sp>
       <p:sp>
         <p:nvSpPr>
-          <p:cNvPr id="16" name="Rounded Rectangle 15"/>
+          <p:cNvPr id="21" name="Rounded Rectangle 20"/>
+          <p:cNvSpPr/>
+          <p:nvPr/>
+        </p:nvSpPr>
+        <p:spPr>
+          <a:xfrm>
+            <a:off x="7022592" y="4727448"/>
+            <a:ext cx="3474720" cy="502920"/>
+          </a:xfrm>
+          <a:prstGeom prst="roundRect">
+            <a:avLst/>
+          </a:prstGeom>
+          <a:solidFill>
+            <a:srgbClr val="002328"/>
+          </a:solidFill>
+          <a:ln>
+            <a:noFill/>
+          </a:ln>
+        </p:spPr>
+        <p:style>
+          <a:lnRef idx="1">
+            <a:schemeClr val="accent1"/>
+          </a:lnRef>
+          <a:fillRef idx="3">
+            <a:schemeClr val="accent1"/>
+          </a:fillRef>
+          <a:effectRef idx="2">
+            <a:schemeClr val="accent1"/>
+          </a:effectRef>
+          <a:fontRef idx="minor">
+            <a:schemeClr val="lt1"/>
+          </a:fontRef>
+        </p:style>
+        <p:txBody>
+          <a:bodyPr rtlCol="0" anchor="ctr"/>
+          <a:lstStyle/>
+          <a:p>
+            <a:pPr algn="ctr"/>
+          </a:p>
+        </p:txBody>
+      </p:sp>
+      <p:sp>
+        <p:nvSpPr>
+          <p:cNvPr id="22" name="Rounded Rectangle 21"/>
           <p:cNvSpPr/>
           <p:nvPr/>
         </p:nvSpPr>
@@ -4565,7 +4995,7 @@
             <a:pPr algn="l">
               <a:defRPr sz="1400" b="0" i="0">
                 <a:solidFill>
-                  <a:srgbClr val="FFFFFF"/>
+                  <a:srgbClr val="C8F2EC"/>
                 </a:solidFill>
                 <a:latin typeface="Calibri"/>
               </a:defRPr>
@@ -4579,6 +5009,49 @@
       <p:sp>
         <p:nvSpPr>
           <p:cNvPr id="5" name="Rounded Rectangle 4"/>
+          <p:cNvSpPr/>
+          <p:nvPr/>
+        </p:nvSpPr>
+        <p:spPr>
+          <a:xfrm>
+            <a:off x="5084064" y="1700784"/>
+            <a:ext cx="6217920" cy="1280160"/>
+          </a:xfrm>
+          <a:prstGeom prst="roundRect">
+            <a:avLst/>
+          </a:prstGeom>
+          <a:solidFill>
+            <a:srgbClr val="00191C"/>
+          </a:solidFill>
+          <a:ln>
+            <a:noFill/>
+          </a:ln>
+        </p:spPr>
+        <p:style>
+          <a:lnRef idx="1">
+            <a:schemeClr val="accent1"/>
+          </a:lnRef>
+          <a:fillRef idx="3">
+            <a:schemeClr val="accent1"/>
+          </a:fillRef>
+          <a:effectRef idx="2">
+            <a:schemeClr val="accent1"/>
+          </a:effectRef>
+          <a:fontRef idx="minor">
+            <a:schemeClr val="lt1"/>
+          </a:fontRef>
+        </p:style>
+        <p:txBody>
+          <a:bodyPr rtlCol="0" anchor="ctr"/>
+          <a:lstStyle/>
+          <a:p>
+            <a:pPr algn="ctr"/>
+          </a:p>
+        </p:txBody>
+      </p:sp>
+      <p:sp>
+        <p:nvSpPr>
+          <p:cNvPr id="6" name="Rounded Rectangle 5"/>
           <p:cNvSpPr/>
           <p:nvPr/>
         </p:nvSpPr>
@@ -4646,7 +5119,50 @@
       </p:sp>
       <p:sp>
         <p:nvSpPr>
-          <p:cNvPr id="6" name="Rounded Rectangle 5"/>
+          <p:cNvPr id="7" name="Rounded Rectangle 6"/>
+          <p:cNvSpPr/>
+          <p:nvPr/>
+        </p:nvSpPr>
+        <p:spPr>
+          <a:xfrm>
+            <a:off x="5084064" y="3209544"/>
+            <a:ext cx="6217920" cy="1280160"/>
+          </a:xfrm>
+          <a:prstGeom prst="roundRect">
+            <a:avLst/>
+          </a:prstGeom>
+          <a:solidFill>
+            <a:srgbClr val="00191C"/>
+          </a:solidFill>
+          <a:ln>
+            <a:noFill/>
+          </a:ln>
+        </p:spPr>
+        <p:style>
+          <a:lnRef idx="1">
+            <a:schemeClr val="accent1"/>
+          </a:lnRef>
+          <a:fillRef idx="3">
+            <a:schemeClr val="accent1"/>
+          </a:fillRef>
+          <a:effectRef idx="2">
+            <a:schemeClr val="accent1"/>
+          </a:effectRef>
+          <a:fontRef idx="minor">
+            <a:schemeClr val="lt1"/>
+          </a:fontRef>
+        </p:style>
+        <p:txBody>
+          <a:bodyPr rtlCol="0" anchor="ctr"/>
+          <a:lstStyle/>
+          <a:p>
+            <a:pPr algn="ctr"/>
+          </a:p>
+        </p:txBody>
+      </p:sp>
+      <p:sp>
+        <p:nvSpPr>
+          <p:cNvPr id="8" name="Rounded Rectangle 7"/>
           <p:cNvSpPr/>
           <p:nvPr/>
         </p:nvSpPr>
@@ -4714,7 +5230,50 @@
       </p:sp>
       <p:sp>
         <p:nvSpPr>
-          <p:cNvPr id="7" name="Rounded Rectangle 6"/>
+          <p:cNvPr id="9" name="Rounded Rectangle 8"/>
+          <p:cNvSpPr/>
+          <p:nvPr/>
+        </p:nvSpPr>
+        <p:spPr>
+          <a:xfrm>
+            <a:off x="5084064" y="4718304"/>
+            <a:ext cx="6217920" cy="1280160"/>
+          </a:xfrm>
+          <a:prstGeom prst="roundRect">
+            <a:avLst/>
+          </a:prstGeom>
+          <a:solidFill>
+            <a:srgbClr val="00191C"/>
+          </a:solidFill>
+          <a:ln>
+            <a:noFill/>
+          </a:ln>
+        </p:spPr>
+        <p:style>
+          <a:lnRef idx="1">
+            <a:schemeClr val="accent1"/>
+          </a:lnRef>
+          <a:fillRef idx="3">
+            <a:schemeClr val="accent1"/>
+          </a:fillRef>
+          <a:effectRef idx="2">
+            <a:schemeClr val="accent1"/>
+          </a:effectRef>
+          <a:fontRef idx="minor">
+            <a:schemeClr val="lt1"/>
+          </a:fontRef>
+        </p:style>
+        <p:txBody>
+          <a:bodyPr rtlCol="0" anchor="ctr"/>
+          <a:lstStyle/>
+          <a:p>
+            <a:pPr algn="ctr"/>
+          </a:p>
+        </p:txBody>
+      </p:sp>
+      <p:sp>
+        <p:nvSpPr>
+          <p:cNvPr id="10" name="Rounded Rectangle 9"/>
           <p:cNvSpPr/>
           <p:nvPr/>
         </p:nvSpPr>
@@ -4970,6 +5529,49 @@
         </p:nvSpPr>
         <p:spPr>
           <a:xfrm>
+            <a:off x="6272784" y="1700784"/>
+            <a:ext cx="5029200" cy="2011680"/>
+          </a:xfrm>
+          <a:prstGeom prst="roundRect">
+            <a:avLst/>
+          </a:prstGeom>
+          <a:solidFill>
+            <a:srgbClr val="D7DEDE"/>
+          </a:solidFill>
+          <a:ln>
+            <a:noFill/>
+          </a:ln>
+        </p:spPr>
+        <p:style>
+          <a:lnRef idx="1">
+            <a:schemeClr val="accent1"/>
+          </a:lnRef>
+          <a:fillRef idx="3">
+            <a:schemeClr val="accent1"/>
+          </a:fillRef>
+          <a:effectRef idx="2">
+            <a:schemeClr val="accent1"/>
+          </a:effectRef>
+          <a:fontRef idx="minor">
+            <a:schemeClr val="lt1"/>
+          </a:fontRef>
+        </p:style>
+        <p:txBody>
+          <a:bodyPr rtlCol="0" anchor="ctr"/>
+          <a:lstStyle/>
+          <a:p>
+            <a:pPr algn="ctr"/>
+          </a:p>
+        </p:txBody>
+      </p:sp>
+      <p:sp>
+        <p:nvSpPr>
+          <p:cNvPr id="7" name="Rounded Rectangle 6"/>
+          <p:cNvSpPr/>
+          <p:nvPr/>
+        </p:nvSpPr>
+        <p:spPr>
+          <a:xfrm>
             <a:off x="6217920" y="1645920"/>
             <a:ext cx="5029200" cy="2011680"/>
           </a:xfrm>
@@ -4979,7 +5581,7 @@
           <a:solidFill>
             <a:srgbClr val="FFFFFF"/>
           </a:solidFill>
-          <a:ln w="19050">
+          <a:ln w="25400">
             <a:solidFill>
               <a:srgbClr val="10B981"/>
             </a:solidFill>
@@ -5049,7 +5651,50 @@
       </p:sp>
       <p:sp>
         <p:nvSpPr>
-          <p:cNvPr id="7" name="Rounded Rectangle 6"/>
+          <p:cNvPr id="8" name="Rounded Rectangle 7"/>
+          <p:cNvSpPr/>
+          <p:nvPr/>
+        </p:nvSpPr>
+        <p:spPr>
+          <a:xfrm>
+            <a:off x="6272784" y="3986784"/>
+            <a:ext cx="5029200" cy="2194560"/>
+          </a:xfrm>
+          <a:prstGeom prst="roundRect">
+            <a:avLst/>
+          </a:prstGeom>
+          <a:solidFill>
+            <a:srgbClr val="D7DEDE"/>
+          </a:solidFill>
+          <a:ln>
+            <a:noFill/>
+          </a:ln>
+        </p:spPr>
+        <p:style>
+          <a:lnRef idx="1">
+            <a:schemeClr val="accent1"/>
+          </a:lnRef>
+          <a:fillRef idx="3">
+            <a:schemeClr val="accent1"/>
+          </a:fillRef>
+          <a:effectRef idx="2">
+            <a:schemeClr val="accent1"/>
+          </a:effectRef>
+          <a:fontRef idx="minor">
+            <a:schemeClr val="lt1"/>
+          </a:fontRef>
+        </p:style>
+        <p:txBody>
+          <a:bodyPr rtlCol="0" anchor="ctr"/>
+          <a:lstStyle/>
+          <a:p>
+            <a:pPr algn="ctr"/>
+          </a:p>
+        </p:txBody>
+      </p:sp>
+      <p:sp>
+        <p:nvSpPr>
+          <p:cNvPr id="9" name="Rounded Rectangle 8"/>
           <p:cNvSpPr/>
           <p:nvPr/>
         </p:nvSpPr>
@@ -5064,7 +5709,7 @@
           <a:solidFill>
             <a:srgbClr val="FFFFFF"/>
           </a:solidFill>
-          <a:ln w="19050">
+          <a:ln w="25400">
             <a:solidFill>
               <a:srgbClr val="DC2626"/>
             </a:solidFill>
@@ -5206,6 +5851,49 @@
         </p:nvSpPr>
         <p:spPr>
           <a:xfrm>
+            <a:off x="978408" y="2075688"/>
+            <a:ext cx="3200400" cy="3657600"/>
+          </a:xfrm>
+          <a:prstGeom prst="roundRect">
+            <a:avLst/>
+          </a:prstGeom>
+          <a:solidFill>
+            <a:srgbClr val="D7DEDE"/>
+          </a:solidFill>
+          <a:ln>
+            <a:noFill/>
+          </a:ln>
+        </p:spPr>
+        <p:style>
+          <a:lnRef idx="1">
+            <a:schemeClr val="accent1"/>
+          </a:lnRef>
+          <a:fillRef idx="3">
+            <a:schemeClr val="accent1"/>
+          </a:fillRef>
+          <a:effectRef idx="2">
+            <a:schemeClr val="accent1"/>
+          </a:effectRef>
+          <a:fontRef idx="minor">
+            <a:schemeClr val="lt1"/>
+          </a:fontRef>
+        </p:style>
+        <p:txBody>
+          <a:bodyPr rtlCol="0" anchor="ctr"/>
+          <a:lstStyle/>
+          <a:p>
+            <a:pPr algn="ctr"/>
+          </a:p>
+        </p:txBody>
+      </p:sp>
+      <p:sp>
+        <p:nvSpPr>
+          <p:cNvPr id="4" name="Rounded Rectangle 3"/>
+          <p:cNvSpPr/>
+          <p:nvPr/>
+        </p:nvSpPr>
+        <p:spPr>
+          <a:xfrm>
             <a:off x="914400" y="2011680"/>
             <a:ext cx="3200400" cy="3657600"/>
           </a:xfrm>
@@ -5280,7 +5968,50 @@
       </p:sp>
       <p:sp>
         <p:nvSpPr>
-          <p:cNvPr id="4" name="Rounded Rectangle 3"/>
+          <p:cNvPr id="5" name="Rounded Rectangle 4"/>
+          <p:cNvSpPr/>
+          <p:nvPr/>
+        </p:nvSpPr>
+        <p:spPr>
+          <a:xfrm>
+            <a:off x="4544568" y="2075688"/>
+            <a:ext cx="3200400" cy="3657600"/>
+          </a:xfrm>
+          <a:prstGeom prst="roundRect">
+            <a:avLst/>
+          </a:prstGeom>
+          <a:solidFill>
+            <a:srgbClr val="D7DEDE"/>
+          </a:solidFill>
+          <a:ln>
+            <a:noFill/>
+          </a:ln>
+        </p:spPr>
+        <p:style>
+          <a:lnRef idx="1">
+            <a:schemeClr val="accent1"/>
+          </a:lnRef>
+          <a:fillRef idx="3">
+            <a:schemeClr val="accent1"/>
+          </a:fillRef>
+          <a:effectRef idx="2">
+            <a:schemeClr val="accent1"/>
+          </a:effectRef>
+          <a:fontRef idx="minor">
+            <a:schemeClr val="lt1"/>
+          </a:fontRef>
+        </p:style>
+        <p:txBody>
+          <a:bodyPr rtlCol="0" anchor="ctr"/>
+          <a:lstStyle/>
+          <a:p>
+            <a:pPr algn="ctr"/>
+          </a:p>
+        </p:txBody>
+      </p:sp>
+      <p:sp>
+        <p:nvSpPr>
+          <p:cNvPr id="6" name="Rounded Rectangle 5"/>
           <p:cNvSpPr/>
           <p:nvPr/>
         </p:nvSpPr>
@@ -5360,7 +6091,50 @@
       </p:sp>
       <p:sp>
         <p:nvSpPr>
-          <p:cNvPr id="5" name="Rounded Rectangle 4"/>
+          <p:cNvPr id="7" name="Rounded Rectangle 6"/>
+          <p:cNvSpPr/>
+          <p:nvPr/>
+        </p:nvSpPr>
+        <p:spPr>
+          <a:xfrm>
+            <a:off x="8110728" y="2075688"/>
+            <a:ext cx="3200400" cy="3657600"/>
+          </a:xfrm>
+          <a:prstGeom prst="roundRect">
+            <a:avLst/>
+          </a:prstGeom>
+          <a:solidFill>
+            <a:srgbClr val="D7DEDE"/>
+          </a:solidFill>
+          <a:ln>
+            <a:noFill/>
+          </a:ln>
+        </p:spPr>
+        <p:style>
+          <a:lnRef idx="1">
+            <a:schemeClr val="accent1"/>
+          </a:lnRef>
+          <a:fillRef idx="3">
+            <a:schemeClr val="accent1"/>
+          </a:fillRef>
+          <a:effectRef idx="2">
+            <a:schemeClr val="accent1"/>
+          </a:effectRef>
+          <a:fontRef idx="minor">
+            <a:schemeClr val="lt1"/>
+          </a:fontRef>
+        </p:style>
+        <p:txBody>
+          <a:bodyPr rtlCol="0" anchor="ctr"/>
+          <a:lstStyle/>
+          <a:p>
+            <a:pPr algn="ctr"/>
+          </a:p>
+        </p:txBody>
+      </p:sp>
+      <p:sp>
+        <p:nvSpPr>
+          <p:cNvPr id="8" name="Rounded Rectangle 7"/>
           <p:cNvSpPr/>
           <p:nvPr/>
         </p:nvSpPr>
@@ -5575,11 +6349,11 @@
             <a:r>
               <a:rPr sz="1400">
                 <a:solidFill>
-                  <a:srgbClr val="00A896"/>
+                  <a:srgbClr val="C8F2EC"/>
                 </a:solidFill>
                 <a:latin typeface="Calibri"/>
               </a:rPr>
-              <a:t>Actively disproves claims instead of search corroboration</a:t>
+              <a:t>Actively disproves claims instead of blindly searching for support</a:t>
             </a:r>
           </a:p>
           <a:p>
@@ -5600,7 +6374,7 @@
             <a:r>
               <a:rPr sz="1400">
                 <a:solidFill>
-                  <a:srgbClr val="00A896"/>
+                  <a:srgbClr val="C8F2EC"/>
                 </a:solidFill>
                 <a:latin typeface="Calibri"/>
               </a:rPr>
@@ -5625,7 +6399,7 @@
             <a:r>
               <a:rPr sz="1400">
                 <a:solidFill>
-                  <a:srgbClr val="00A896"/>
+                  <a:srgbClr val="C8F2EC"/>
                 </a:solidFill>
                 <a:latin typeface="Calibri"/>
               </a:rPr>
@@ -5659,7 +6433,7 @@
             <a:pPr algn="l">
               <a:defRPr sz="1200" b="1" i="0">
                 <a:solidFill>
-                  <a:srgbClr val="00A896"/>
+                  <a:srgbClr val="02C39A"/>
                 </a:solidFill>
                 <a:latin typeface="Calibri"/>
               </a:defRPr>

</xml_diff>